<commit_message>
Add the Bluetooth line to the PS3 cheat sheet and decks
The cheat sheet's "At the top" block now shows the include, so sketches
students write themselves start Bluetooth too. Rebuilding the L3 and L5
decks moves three line numbers that srcfacts reads from l3c and l5c.

Co-Authored-By: Claude Opus 5.5 <noreply@anthropic.com>
</commit_message>
<xml_diff>
--- a/ground-vehicle/docs/courses/beginner-ps3/l3_controller_programming.pptx
+++ b/ground-vehicle/docs/courses/beginner-ps3/l3_controller_programming.pptx
@@ -17506,7 +17506,7 @@
                 </a:solidFill>
                 <a:latin typeface="Calibri"/>
               </a:rPr>
-              <a:t>5.  Lines 168 and 169: swap the + and the - and drive. What is wrong now?</a:t>
+              <a:t>5.  Lines 173 and 174: swap the + and the - and drive. What is wrong now?</a:t>
             </a:r>
           </a:p>
           <a:p>
@@ -17531,7 +17531,7 @@
                 </a:solidFill>
                 <a:latin typeface="Calibri"/>
               </a:rPr>
-              <a:t>6.  Line 169: make it  rightSpeed = forward;  with no turn term. Why is that worse steering?</a:t>
+              <a:t>6.  Line 174: make it  rightSpeed = forward;  with no turn term. Why is that worse steering?</a:t>
             </a:r>
           </a:p>
         </p:txBody>

</xml_diff>